<commit_message>
add dataset download code to notebooks
</commit_message>
<xml_diff>
--- a/Lectures/Projects/Projects.pptx
+++ b/Lectures/Projects/Projects.pptx
@@ -18,9 +18,9 @@
     <p:sldId id="1087" r:id="rId6"/>
     <p:sldId id="1092" r:id="rId7"/>
     <p:sldId id="1090" r:id="rId8"/>
-    <p:sldId id="1089" r:id="rId9"/>
-    <p:sldId id="1085" r:id="rId10"/>
-    <p:sldId id="1086" r:id="rId11"/>
+    <p:sldId id="1085" r:id="rId9"/>
+    <p:sldId id="1086" r:id="rId10"/>
+    <p:sldId id="1093" r:id="rId11"/>
   </p:sldIdLst>
   <p:sldSz cx="9144000" cy="6858000" type="letter"/>
   <p:notesSz cx="9601200" cy="7315200"/>
@@ -3085,7 +3085,7 @@
         <p:cNvPr id="1" name="">
           <a:extLst>
             <a:ext uri="{FF2B5EF4-FFF2-40B4-BE49-F238E27FC236}">
-              <a16:creationId xmlns:a16="http://schemas.microsoft.com/office/drawing/2014/main" id="{2D38A5AF-461D-C51D-EF42-F91E6FE335EF}"/>
+              <a16:creationId xmlns:a16="http://schemas.microsoft.com/office/drawing/2014/main" id="{529F7900-F394-CCD0-3524-7DB80F428A44}"/>
             </a:ext>
           </a:extLst>
         </p:cNvPr>
@@ -3105,7 +3105,7 @@
           <p:cNvPr id="8" name="Content Placeholder 7">
             <a:extLst>
               <a:ext uri="{FF2B5EF4-FFF2-40B4-BE49-F238E27FC236}">
-                <a16:creationId xmlns:a16="http://schemas.microsoft.com/office/drawing/2014/main" id="{36EBA238-9761-443C-E110-F9D0F75D067A}"/>
+                <a16:creationId xmlns:a16="http://schemas.microsoft.com/office/drawing/2014/main" id="{27A6BA8D-317D-22D5-8C7B-8E4C1E78DC1D}"/>
               </a:ext>
             </a:extLst>
           </p:cNvPr>
@@ -3126,55 +3126,35 @@
           <a:bodyPr/>
           <a:lstStyle/>
           <a:p>
-            <a:pPr marL="514350" indent="-514350">
-              <a:buFont typeface="+mj-lt"/>
-              <a:buAutoNum type="arabicPeriod"/>
+            <a:pPr marL="0" indent="0">
+              <a:buNone/>
+            </a:pPr>
+            <a:endParaRPr lang="en-US" dirty="0"/>
+          </a:p>
+          <a:p>
+            <a:pPr marL="0" indent="0">
+              <a:buNone/>
             </a:pPr>
             <a:r>
               <a:rPr lang="en-US" dirty="0"/>
-              <a:t>Class time (both Tuesdays and Thursdays) will be devoted your project. You’re strongly advised to show up!</a:t>
-            </a:r>
-            <a:br>
+              <a:t>	</a:t>
+            </a:r>
+          </a:p>
+          <a:p>
+            <a:pPr marL="0" indent="0">
+              <a:buNone/>
+            </a:pPr>
+            <a:r>
               <a:rPr lang="en-US" dirty="0"/>
-            </a:br>
-            <a:endParaRPr lang="en-US" dirty="0"/>
-          </a:p>
-          <a:p>
-            <a:pPr marL="514350" indent="-514350">
-              <a:buFont typeface="+mj-lt"/>
-              <a:buAutoNum type="arabicPeriod"/>
-            </a:pPr>
+              <a:t>	Tuesday December 2</a:t>
+            </a:r>
+            <a:r>
+              <a:rPr lang="en-US" baseline="30000" dirty="0"/>
+              <a:t>nd</a:t>
+            </a:r>
             <a:r>
               <a:rPr lang="en-US" dirty="0"/>
-              <a:t>You are free to help each other, but your paper must be your own.</a:t>
-            </a:r>
-            <a:br>
-              <a:rPr lang="en-US" dirty="0"/>
-            </a:br>
-            <a:endParaRPr lang="en-US" dirty="0"/>
-          </a:p>
-          <a:p>
-            <a:pPr marL="514350" indent="-514350">
-              <a:buFont typeface="+mj-lt"/>
-              <a:buAutoNum type="arabicPeriod"/>
-            </a:pPr>
-            <a:r>
-              <a:rPr lang="en-US" dirty="0"/>
-              <a:t>You are free to use any resources, but you must cite all of them.</a:t>
-            </a:r>
-            <a:br>
-              <a:rPr lang="en-US" dirty="0"/>
-            </a:br>
-            <a:endParaRPr lang="en-US" dirty="0"/>
-          </a:p>
-          <a:p>
-            <a:pPr marL="514350" indent="-514350">
-              <a:buFont typeface="+mj-lt"/>
-              <a:buAutoNum type="arabicPeriod"/>
-            </a:pPr>
-            <a:r>
-              <a:rPr lang="en-US" dirty="0"/>
-              <a:t>You must document the data used, the architecture of your model, the training protocol and the results.</a:t>
+              <a:t>, 2025 @ 11:59PM</a:t>
             </a:r>
             <a:br>
               <a:rPr lang="en-US" dirty="0"/>
@@ -3197,7 +3177,7 @@
           <p:cNvPr id="7" name="Title 6">
             <a:extLst>
               <a:ext uri="{FF2B5EF4-FFF2-40B4-BE49-F238E27FC236}">
-                <a16:creationId xmlns:a16="http://schemas.microsoft.com/office/drawing/2014/main" id="{0C0FF786-FAA9-F3FC-5433-937C3E994692}"/>
+                <a16:creationId xmlns:a16="http://schemas.microsoft.com/office/drawing/2014/main" id="{6941F148-560B-BC0D-D20F-01D03F761070}"/>
               </a:ext>
             </a:extLst>
           </p:cNvPr>
@@ -3215,7 +3195,7 @@
           <a:p>
             <a:r>
               <a:rPr lang="en-US" dirty="0"/>
-              <a:t>Ground Rules</a:t>
+              <a:t>Deadline</a:t>
             </a:r>
             <a:endParaRPr lang="en-US" dirty="0">
               <a:solidFill>
@@ -3228,20 +3208,20 @@
     </p:spTree>
     <p:extLst>
       <p:ext uri="{BB962C8B-B14F-4D97-AF65-F5344CB8AC3E}">
-        <p14:creationId xmlns:p14="http://schemas.microsoft.com/office/powerpoint/2010/main" val="4132763623"/>
+        <p14:creationId xmlns:p14="http://schemas.microsoft.com/office/powerpoint/2010/main" val="916649023"/>
       </p:ext>
     </p:extLst>
   </p:cSld>
   <p:clrMapOvr>
     <a:masterClrMapping/>
   </p:clrMapOvr>
-  <mc:AlternateContent xmlns:mc="http://schemas.openxmlformats.org/markup-compatibility/2006" xmlns:p14="http://schemas.microsoft.com/office/powerpoint/2010/main">
-    <mc:Choice Requires="p14">
+  <mc:AlternateContent xmlns:mc="http://schemas.openxmlformats.org/markup-compatibility/2006">
+    <mc:Choice xmlns:p14="http://schemas.microsoft.com/office/powerpoint/2010/main" Requires="p14">
       <p:transition spd="med" p14:dur="700">
         <p:fade/>
       </p:transition>
     </mc:Choice>
-    <mc:Fallback xmlns="">
+    <mc:Fallback>
       <p:transition spd="med">
         <p:fade/>
       </p:transition>
@@ -3315,7 +3295,7 @@
             </a:pPr>
             <a:r>
               <a:rPr lang="en-US" dirty="0"/>
-              <a:t>Use a machine-learning model to solve one of the following classes of problem: </a:t>
+              <a:t>Use a machine-learning model of your choice to solve a problem of interest to you. This could be one of the following classes of problem: </a:t>
             </a:r>
             <a:r>
               <a:rPr lang="en-US" dirty="0">
@@ -3347,11 +3327,11 @@
                   <a:srgbClr val="0033CC"/>
                 </a:solidFill>
               </a:rPr>
-              <a:t>anomaly detection</a:t>
+              <a:t>data compression, structure detection</a:t>
             </a:r>
             <a:r>
               <a:rPr lang="en-US" dirty="0"/>
-              <a:t>, or an </a:t>
+              <a:t>, or solving an </a:t>
             </a:r>
             <a:r>
               <a:rPr lang="en-US" dirty="0">
@@ -3380,19 +3360,15 @@
             </a:pPr>
             <a:r>
               <a:rPr lang="en-US" dirty="0"/>
-              <a:t>Document the project in a short paper using the </a:t>
-            </a:r>
-            <a:r>
-              <a:rPr lang="en-US" dirty="0" err="1">
-                <a:solidFill>
-                  <a:srgbClr val="0033CC"/>
-                </a:solidFill>
-              </a:rPr>
-              <a:t>cernrep</a:t>
+              <a:t>Document the project in a </a:t>
+            </a:r>
+            <a:r>
+              <a:rPr lang="en-US" dirty="0" err="1"/>
+              <a:t>jupyter</a:t>
             </a:r>
             <a:r>
               <a:rPr lang="en-US" dirty="0"/>
-              <a:t> LaTeX package.</a:t>
+              <a:t> notebook.</a:t>
             </a:r>
             <a:br>
               <a:rPr lang="en-US" dirty="0"/>
@@ -3537,7 +3513,7 @@
                 </a:r>
                 <a:r>
                   <a:rPr lang="en-US" dirty="0"/>
-                  <a:t>Choose a problem from your field or tackle one of the following problems.</a:t>
+                  <a:t>Choose a problem from your field (if you’re a graduate student) or you may tackle one of the following problems:</a:t>
                 </a:r>
               </a:p>
               <a:p>
@@ -3553,7 +3529,7 @@
                 </a:pPr>
                 <a:r>
                   <a:rPr lang="en-US" dirty="0"/>
-                  <a:t>Jet image classification.</a:t>
+                  <a:t>Jet classification (gluon vs. quark-initiated jets)</a:t>
                 </a:r>
                 <a:br>
                   <a:rPr lang="en-US" dirty="0"/>
@@ -3625,30 +3601,8 @@
                 </a:r>
               </a:p>
               <a:p>
-                <a:pPr marL="514350" indent="-514350">
-                  <a:buFont typeface="+mj-lt"/>
-                  <a:buAutoNum type="arabicPeriod"/>
-                </a:pPr>
-                <a:endParaRPr lang="en-US" dirty="0">
-                  <a:latin typeface="+mn-lt"/>
-                </a:endParaRPr>
-              </a:p>
-              <a:p>
-                <a:pPr marL="514350" indent="-514350">
-                  <a:buFont typeface="+mj-lt"/>
-                  <a:buAutoNum type="arabicPeriod"/>
-                </a:pPr>
-                <a:r>
-                  <a:rPr lang="en-US" dirty="0">
-                    <a:latin typeface="+mn-lt"/>
-                  </a:rPr>
-                  <a:t>Anomaly detection.</a:t>
-                </a:r>
-              </a:p>
-              <a:p>
-                <a:pPr marL="514350" indent="-514350">
-                  <a:buFont typeface="+mj-lt"/>
-                  <a:buAutoNum type="arabicPeriod"/>
+                <a:pPr marL="0" indent="0">
+                  <a:buNone/>
                 </a:pPr>
                 <a:endParaRPr lang="en-US" dirty="0"/>
               </a:p>
@@ -3693,7 +3647,7 @@
               <a:blipFill>
                 <a:blip r:embed="rId2"/>
                 <a:stretch>
-                  <a:fillRect l="-1274" t="-1316" r="-1911"/>
+                  <a:fillRect l="-1274" t="-1316"/>
                 </a:stretch>
               </a:blipFill>
             </p:spPr>
@@ -3860,12 +3814,12 @@
               <a:buNone/>
             </a:pPr>
             <a:r>
-              <a:rPr lang="en-US" dirty="0">
+              <a:rPr lang="en-US" b="1" dirty="0">
                 <a:solidFill>
                   <a:srgbClr val="0033CC"/>
                 </a:solidFill>
               </a:rPr>
-              <a:t>Problem</a:t>
+              <a:t>Problem 1</a:t>
             </a:r>
             <a:r>
               <a:rPr lang="en-US" dirty="0">
@@ -4251,12 +4205,12 @@
               <a:buNone/>
             </a:pPr>
             <a:r>
-              <a:rPr lang="en-US" dirty="0">
+              <a:rPr lang="en-US" b="1" dirty="0">
                 <a:solidFill>
                   <a:srgbClr val="0033CC"/>
                 </a:solidFill>
               </a:rPr>
-              <a:t>Problem</a:t>
+              <a:t>Problem 2</a:t>
             </a:r>
             <a:r>
               <a:rPr lang="en-US" dirty="0">
@@ -4563,12 +4517,12 @@
               <a:buNone/>
             </a:pPr>
             <a:r>
-              <a:rPr lang="en-US" dirty="0">
+              <a:rPr lang="en-US" b="1" dirty="0">
                 <a:solidFill>
                   <a:srgbClr val="0033CC"/>
                 </a:solidFill>
               </a:rPr>
-              <a:t>Problem</a:t>
+              <a:t>Problem 2</a:t>
             </a:r>
             <a:r>
               <a:rPr lang="en-US" dirty="0">
@@ -4864,8 +4818,8 @@
           <a:chExt cx="0" cy="0"/>
         </a:xfrm>
       </p:grpSpPr>
-      <mc:AlternateContent xmlns:mc="http://schemas.openxmlformats.org/markup-compatibility/2006" xmlns:a14="http://schemas.microsoft.com/office/drawing/2010/main">
-        <mc:Choice Requires="a14">
+      <mc:AlternateContent xmlns:mc="http://schemas.openxmlformats.org/markup-compatibility/2006">
+        <mc:Choice xmlns:a14="http://schemas.microsoft.com/office/drawing/2010/main" Requires="a14">
           <p:sp>
             <p:nvSpPr>
               <p:cNvPr id="8" name="Content Placeholder 7">
@@ -4896,12 +4850,12 @@
                   <a:buNone/>
                 </a:pPr>
                 <a:r>
-                  <a:rPr lang="en-US" dirty="0">
+                  <a:rPr lang="en-US" b="1" dirty="0">
                     <a:solidFill>
                       <a:srgbClr val="0033CC"/>
                     </a:solidFill>
                   </a:rPr>
-                  <a:t>Problem</a:t>
+                  <a:t>Problem 3</a:t>
                 </a:r>
                 <a:r>
                   <a:rPr lang="en-US" dirty="0">
@@ -5749,7 +5703,7 @@
             </p:txBody>
           </p:sp>
         </mc:Choice>
-        <mc:Fallback xmlns="">
+        <mc:Fallback>
           <p:sp>
             <p:nvSpPr>
               <p:cNvPr id="8" name="Content Placeholder 7">
@@ -5859,608 +5813,6 @@
         <p:cNvPr id="1" name="">
           <a:extLst>
             <a:ext uri="{FF2B5EF4-FFF2-40B4-BE49-F238E27FC236}">
-              <a16:creationId xmlns:a16="http://schemas.microsoft.com/office/drawing/2014/main" id="{B22B80A5-04AD-FE51-8D0E-BDEA20C2D570}"/>
-            </a:ext>
-          </a:extLst>
-        </p:cNvPr>
-        <p:cNvGrpSpPr/>
-        <p:nvPr/>
-      </p:nvGrpSpPr>
-      <p:grpSpPr>
-        <a:xfrm>
-          <a:off x="0" y="0"/>
-          <a:ext cx="0" cy="0"/>
-          <a:chOff x="0" y="0"/>
-          <a:chExt cx="0" cy="0"/>
-        </a:xfrm>
-      </p:grpSpPr>
-      <mc:AlternateContent xmlns:mc="http://schemas.openxmlformats.org/markup-compatibility/2006" xmlns:a14="http://schemas.microsoft.com/office/drawing/2010/main">
-        <mc:Choice Requires="a14">
-          <p:sp>
-            <p:nvSpPr>
-              <p:cNvPr id="8" name="Content Placeholder 7">
-                <a:extLst>
-                  <a:ext uri="{FF2B5EF4-FFF2-40B4-BE49-F238E27FC236}">
-                    <a16:creationId xmlns:a16="http://schemas.microsoft.com/office/drawing/2014/main" id="{8D840D64-988A-B2AF-C8A3-9D1A4702914B}"/>
-                  </a:ext>
-                </a:extLst>
-              </p:cNvPr>
-              <p:cNvSpPr>
-                <a:spLocks noGrp="1"/>
-              </p:cNvSpPr>
-              <p:nvPr>
-                <p:ph idx="1"/>
-              </p:nvPr>
-            </p:nvSpPr>
-            <p:spPr>
-              <a:xfrm>
-                <a:off x="711200" y="1295400"/>
-                <a:ext cx="7975600" cy="4819650"/>
-              </a:xfrm>
-            </p:spPr>
-            <p:txBody>
-              <a:bodyPr/>
-              <a:lstStyle/>
-              <a:p>
-                <a:pPr marL="0" indent="0">
-                  <a:buNone/>
-                </a:pPr>
-                <a:r>
-                  <a:rPr lang="en-US" dirty="0">
-                    <a:solidFill>
-                      <a:srgbClr val="0033CC"/>
-                    </a:solidFill>
-                  </a:rPr>
-                  <a:t>Problem</a:t>
-                </a:r>
-                <a:r>
-                  <a:rPr lang="en-US" dirty="0">
-                    <a:solidFill>
-                      <a:srgbClr val="0033CC"/>
-                    </a:solidFill>
-                    <a:latin typeface="+mn-lt"/>
-                  </a:rPr>
-                  <a:t>: </a:t>
-                </a:r>
-                <a:r>
-                  <a:rPr lang="en-US" dirty="0">
-                    <a:latin typeface="+mn-lt"/>
-                  </a:rPr>
-                  <a:t>Detect an unknown signal in a dataset.</a:t>
-                </a:r>
-              </a:p>
-              <a:p>
-                <a:pPr marL="0" indent="0">
-                  <a:buNone/>
-                </a:pPr>
-                <a:endParaRPr lang="en-US" dirty="0">
-                  <a:latin typeface="+mn-lt"/>
-                </a:endParaRPr>
-              </a:p>
-              <a:p>
-                <a:pPr marL="0" indent="0">
-                  <a:buNone/>
-                </a:pPr>
-                <a:r>
-                  <a:rPr lang="en-US" dirty="0">
-                    <a:solidFill>
-                      <a:srgbClr val="0033CC"/>
-                    </a:solidFill>
-                    <a:latin typeface="+mn-lt"/>
-                  </a:rPr>
-                  <a:t>Dataset</a:t>
-                </a:r>
-                <a:r>
-                  <a:rPr lang="en-US" dirty="0">
-                    <a:latin typeface="+mn-lt"/>
-                  </a:rPr>
-                  <a:t>: Data comprising a mixture of mostly background plus a small signal and another containing background only.</a:t>
-                </a:r>
-              </a:p>
-              <a:p>
-                <a:pPr marL="0" indent="0">
-                  <a:buNone/>
-                </a:pPr>
-                <a:endParaRPr lang="en-US" dirty="0">
-                  <a:latin typeface="+mn-lt"/>
-                </a:endParaRPr>
-              </a:p>
-              <a:p>
-                <a:pPr marL="0" indent="0">
-                  <a:buNone/>
-                </a:pPr>
-                <a:r>
-                  <a:rPr lang="en-US" dirty="0">
-                    <a:solidFill>
-                      <a:srgbClr val="0033CC"/>
-                    </a:solidFill>
-                    <a:latin typeface="+mn-lt"/>
-                  </a:rPr>
-                  <a:t>Anomaly Detector</a:t>
-                </a:r>
-                <a:r>
-                  <a:rPr lang="en-US" dirty="0">
-                    <a:latin typeface="+mn-lt"/>
-                  </a:rPr>
-                  <a:t>:</a:t>
-                </a:r>
-                <a:endParaRPr lang="en-US" dirty="0"/>
-              </a:p>
-              <a:p>
-                <a:pPr marL="0" indent="0">
-                  <a:buNone/>
-                </a:pPr>
-                <a14:m>
-                  <m:oMathPara xmlns:m="http://schemas.openxmlformats.org/officeDocument/2006/math">
-                    <m:oMathParaPr>
-                      <m:jc m:val="centerGroup"/>
-                    </m:oMathParaPr>
-                    <m:oMath xmlns:m="http://schemas.openxmlformats.org/officeDocument/2006/math">
-                      <m:f>
-                        <m:fPr>
-                          <m:ctrlPr>
-                            <a:rPr lang="en-US" i="1" smtClean="0">
-                              <a:latin typeface="Cambria Math" panose="02040503050406030204" pitchFamily="18" charset="0"/>
-                            </a:rPr>
-                          </m:ctrlPr>
-                        </m:fPr>
-                        <m:num>
-                          <m:sSub>
-                            <m:sSubPr>
-                              <m:ctrlPr>
-                                <a:rPr lang="en-US" b="0" i="1" smtClean="0">
-                                  <a:latin typeface="Cambria Math" panose="02040503050406030204" pitchFamily="18" charset="0"/>
-                                </a:rPr>
-                              </m:ctrlPr>
-                            </m:sSubPr>
-                            <m:e>
-                              <m:r>
-                                <a:rPr lang="en-US" b="0" i="1" smtClean="0">
-                                  <a:latin typeface="Cambria Math" panose="02040503050406030204" pitchFamily="18" charset="0"/>
-                                </a:rPr>
-                                <m:t>𝑝</m:t>
-                              </m:r>
-                            </m:e>
-                            <m:sub>
-                              <m:r>
-                                <a:rPr lang="en-US" b="0" i="1" smtClean="0">
-                                  <a:latin typeface="Cambria Math" panose="02040503050406030204" pitchFamily="18" charset="0"/>
-                                </a:rPr>
-                                <m:t>𝑑𝑎𝑡𝑎</m:t>
-                              </m:r>
-                            </m:sub>
-                          </m:sSub>
-                          <m:r>
-                            <a:rPr lang="en-US" b="0" i="1" smtClean="0">
-                              <a:latin typeface="Cambria Math" panose="02040503050406030204" pitchFamily="18" charset="0"/>
-                            </a:rPr>
-                            <m:t>(</m:t>
-                          </m:r>
-                          <m:r>
-                            <a:rPr lang="en-US" b="0" i="1" smtClean="0">
-                              <a:latin typeface="Cambria Math" panose="02040503050406030204" pitchFamily="18" charset="0"/>
-                            </a:rPr>
-                            <m:t>𝑥</m:t>
-                          </m:r>
-                          <m:r>
-                            <a:rPr lang="en-US" b="0" i="1" smtClean="0">
-                              <a:latin typeface="Cambria Math" panose="02040503050406030204" pitchFamily="18" charset="0"/>
-                            </a:rPr>
-                            <m:t>)</m:t>
-                          </m:r>
-                        </m:num>
-                        <m:den>
-                          <m:sSub>
-                            <m:sSubPr>
-                              <m:ctrlPr>
-                                <a:rPr lang="en-US" b="0" i="1" smtClean="0">
-                                  <a:latin typeface="Cambria Math" panose="02040503050406030204" pitchFamily="18" charset="0"/>
-                                </a:rPr>
-                              </m:ctrlPr>
-                            </m:sSubPr>
-                            <m:e>
-                              <m:r>
-                                <a:rPr lang="en-US" b="0" i="1" smtClean="0">
-                                  <a:latin typeface="Cambria Math" panose="02040503050406030204" pitchFamily="18" charset="0"/>
-                                </a:rPr>
-                                <m:t>𝑝</m:t>
-                              </m:r>
-                            </m:e>
-                            <m:sub>
-                              <m:r>
-                                <a:rPr lang="en-US" b="0" i="1" smtClean="0">
-                                  <a:latin typeface="Cambria Math" panose="02040503050406030204" pitchFamily="18" charset="0"/>
-                                </a:rPr>
-                                <m:t>𝑏𝑘𝑔</m:t>
-                              </m:r>
-                            </m:sub>
-                          </m:sSub>
-                          <m:r>
-                            <a:rPr lang="en-US" b="0" i="1" smtClean="0">
-                              <a:latin typeface="Cambria Math" panose="02040503050406030204" pitchFamily="18" charset="0"/>
-                            </a:rPr>
-                            <m:t>(</m:t>
-                          </m:r>
-                          <m:r>
-                            <a:rPr lang="en-US" b="0" i="1" smtClean="0">
-                              <a:latin typeface="Cambria Math" panose="02040503050406030204" pitchFamily="18" charset="0"/>
-                            </a:rPr>
-                            <m:t>𝑥</m:t>
-                          </m:r>
-                          <m:r>
-                            <a:rPr lang="en-US" b="0" i="1" smtClean="0">
-                              <a:latin typeface="Cambria Math" panose="02040503050406030204" pitchFamily="18" charset="0"/>
-                            </a:rPr>
-                            <m:t>)</m:t>
-                          </m:r>
-                        </m:den>
-                      </m:f>
-                      <m:r>
-                        <a:rPr lang="en-US" b="0" i="1" smtClean="0">
-                          <a:latin typeface="Cambria Math" panose="02040503050406030204" pitchFamily="18" charset="0"/>
-                        </a:rPr>
-                        <m:t>&gt;</m:t>
-                      </m:r>
-                      <m:r>
-                        <a:rPr lang="en-US" b="0" i="1" smtClean="0">
-                          <a:latin typeface="Cambria Math" panose="02040503050406030204" pitchFamily="18" charset="0"/>
-                        </a:rPr>
-                        <m:t>𝑡</m:t>
-                      </m:r>
-                    </m:oMath>
-                  </m:oMathPara>
-                </a14:m>
-                <a:endParaRPr lang="en-US" dirty="0"/>
-              </a:p>
-              <a:p>
-                <a:pPr marL="0" indent="0">
-                  <a:buNone/>
-                </a:pPr>
-                <a:r>
-                  <a:rPr lang="en-US" dirty="0"/>
-                  <a:t>where </a:t>
-                </a:r>
-                <a14:m>
-                  <m:oMath xmlns:m="http://schemas.openxmlformats.org/officeDocument/2006/math">
-                    <m:r>
-                      <a:rPr lang="en-US" b="0" i="1" smtClean="0">
-                        <a:solidFill>
-                          <a:srgbClr val="0033CC"/>
-                        </a:solidFill>
-                        <a:latin typeface="Cambria Math" panose="02040503050406030204" pitchFamily="18" charset="0"/>
-                      </a:rPr>
-                      <m:t>𝑡</m:t>
-                    </m:r>
-                  </m:oMath>
-                </a14:m>
-                <a:r>
-                  <a:rPr lang="en-US" dirty="0"/>
-                  <a:t> is the threshold above which you declare </a:t>
-                </a:r>
-                <a14:m>
-                  <m:oMath xmlns:m="http://schemas.openxmlformats.org/officeDocument/2006/math">
-                    <m:r>
-                      <a:rPr lang="en-US" i="1">
-                        <a:solidFill>
-                          <a:srgbClr val="0033CC"/>
-                        </a:solidFill>
-                        <a:latin typeface="Cambria Math" panose="02040503050406030204" pitchFamily="18" charset="0"/>
-                      </a:rPr>
-                      <m:t>𝑥</m:t>
-                    </m:r>
-                  </m:oMath>
-                </a14:m>
-                <a:r>
-                  <a:rPr lang="en-US" dirty="0"/>
-                  <a:t> to be a</a:t>
-                </a:r>
-                <a:r>
-                  <a:rPr lang="en-US" dirty="0">
-                    <a:solidFill>
-                      <a:srgbClr val="0033CC"/>
-                    </a:solidFill>
-                  </a:rPr>
-                  <a:t> </a:t>
-                </a:r>
-                <a:r>
-                  <a:rPr lang="en-US" dirty="0"/>
-                  <a:t>signal. You can assume that</a:t>
-                </a:r>
-              </a:p>
-              <a:p>
-                <a:pPr marL="0" indent="0" algn="ctr">
-                  <a:buNone/>
-                </a:pPr>
-                <a14:m>
-                  <m:oMath xmlns:m="http://schemas.openxmlformats.org/officeDocument/2006/math">
-                    <m:sSub>
-                      <m:sSubPr>
-                        <m:ctrlPr>
-                          <a:rPr lang="en-US" b="0" i="1" smtClean="0">
-                            <a:latin typeface="Cambria Math" panose="02040503050406030204" pitchFamily="18" charset="0"/>
-                          </a:rPr>
-                        </m:ctrlPr>
-                      </m:sSubPr>
-                      <m:e>
-                        <m:r>
-                          <a:rPr lang="en-US" b="0" i="1" smtClean="0">
-                            <a:latin typeface="Cambria Math" panose="02040503050406030204" pitchFamily="18" charset="0"/>
-                          </a:rPr>
-                          <m:t>𝑝</m:t>
-                        </m:r>
-                      </m:e>
-                      <m:sub>
-                        <m:r>
-                          <a:rPr lang="en-US" b="0" i="1" smtClean="0">
-                            <a:latin typeface="Cambria Math" panose="02040503050406030204" pitchFamily="18" charset="0"/>
-                          </a:rPr>
-                          <m:t>𝑑𝑎𝑡𝑎</m:t>
-                        </m:r>
-                      </m:sub>
-                    </m:sSub>
-                    <m:d>
-                      <m:dPr>
-                        <m:ctrlPr>
-                          <a:rPr lang="en-US" b="0" i="1" smtClean="0">
-                            <a:latin typeface="Cambria Math" panose="02040503050406030204" pitchFamily="18" charset="0"/>
-                          </a:rPr>
-                        </m:ctrlPr>
-                      </m:dPr>
-                      <m:e>
-                        <m:r>
-                          <a:rPr lang="en-US" b="0" i="1" smtClean="0">
-                            <a:latin typeface="Cambria Math" panose="02040503050406030204" pitchFamily="18" charset="0"/>
-                          </a:rPr>
-                          <m:t>𝑥</m:t>
-                        </m:r>
-                      </m:e>
-                    </m:d>
-                    <m:r>
-                      <a:rPr lang="en-US" b="0" i="1" smtClean="0">
-                        <a:latin typeface="Cambria Math" panose="02040503050406030204" pitchFamily="18" charset="0"/>
-                      </a:rPr>
-                      <m:t>=</m:t>
-                    </m:r>
-                    <m:r>
-                      <a:rPr lang="en-US" b="0" i="1" smtClean="0">
-                        <a:latin typeface="Cambria Math" panose="02040503050406030204" pitchFamily="18" charset="0"/>
-                      </a:rPr>
-                      <m:t>𝜖</m:t>
-                    </m:r>
-                    <m:sSub>
-                      <m:sSubPr>
-                        <m:ctrlPr>
-                          <a:rPr lang="en-US" b="0" i="1" smtClean="0">
-                            <a:latin typeface="Cambria Math" panose="02040503050406030204" pitchFamily="18" charset="0"/>
-                          </a:rPr>
-                        </m:ctrlPr>
-                      </m:sSubPr>
-                      <m:e>
-                        <m:r>
-                          <a:rPr lang="en-US" b="0" i="1" smtClean="0">
-                            <a:latin typeface="Cambria Math" panose="02040503050406030204" pitchFamily="18" charset="0"/>
-                          </a:rPr>
-                          <m:t>𝑝</m:t>
-                        </m:r>
-                      </m:e>
-                      <m:sub>
-                        <m:r>
-                          <a:rPr lang="en-US" b="0" i="1" smtClean="0">
-                            <a:latin typeface="Cambria Math" panose="02040503050406030204" pitchFamily="18" charset="0"/>
-                          </a:rPr>
-                          <m:t>𝑠𝑖𝑔</m:t>
-                        </m:r>
-                      </m:sub>
-                    </m:sSub>
-                    <m:d>
-                      <m:dPr>
-                        <m:ctrlPr>
-                          <a:rPr lang="en-US" b="0" i="1" smtClean="0">
-                            <a:latin typeface="Cambria Math" panose="02040503050406030204" pitchFamily="18" charset="0"/>
-                          </a:rPr>
-                        </m:ctrlPr>
-                      </m:dPr>
-                      <m:e>
-                        <m:r>
-                          <a:rPr lang="en-US" b="0" i="1" smtClean="0">
-                            <a:latin typeface="Cambria Math" panose="02040503050406030204" pitchFamily="18" charset="0"/>
-                          </a:rPr>
-                          <m:t>𝑥</m:t>
-                        </m:r>
-                      </m:e>
-                    </m:d>
-                    <m:r>
-                      <a:rPr lang="en-US" b="0" i="1" smtClean="0">
-                        <a:latin typeface="Cambria Math" panose="02040503050406030204" pitchFamily="18" charset="0"/>
-                      </a:rPr>
-                      <m:t>+</m:t>
-                    </m:r>
-                    <m:d>
-                      <m:dPr>
-                        <m:ctrlPr>
-                          <a:rPr lang="en-US" b="0" i="1" smtClean="0">
-                            <a:latin typeface="Cambria Math" panose="02040503050406030204" pitchFamily="18" charset="0"/>
-                          </a:rPr>
-                        </m:ctrlPr>
-                      </m:dPr>
-                      <m:e>
-                        <m:r>
-                          <a:rPr lang="en-US" b="0" i="1" smtClean="0">
-                            <a:latin typeface="Cambria Math" panose="02040503050406030204" pitchFamily="18" charset="0"/>
-                          </a:rPr>
-                          <m:t>1−</m:t>
-                        </m:r>
-                        <m:r>
-                          <a:rPr lang="en-US" b="0" i="1" smtClean="0">
-                            <a:latin typeface="Cambria Math" panose="02040503050406030204" pitchFamily="18" charset="0"/>
-                          </a:rPr>
-                          <m:t>𝜖</m:t>
-                        </m:r>
-                      </m:e>
-                    </m:d>
-                    <m:sSub>
-                      <m:sSubPr>
-                        <m:ctrlPr>
-                          <a:rPr lang="en-US" b="0" i="1" smtClean="0">
-                            <a:latin typeface="Cambria Math" panose="02040503050406030204" pitchFamily="18" charset="0"/>
-                          </a:rPr>
-                        </m:ctrlPr>
-                      </m:sSubPr>
-                      <m:e>
-                        <m:r>
-                          <a:rPr lang="en-US" b="0" i="1" smtClean="0">
-                            <a:latin typeface="Cambria Math" panose="02040503050406030204" pitchFamily="18" charset="0"/>
-                          </a:rPr>
-                          <m:t>𝑝</m:t>
-                        </m:r>
-                      </m:e>
-                      <m:sub>
-                        <m:r>
-                          <a:rPr lang="en-US" b="0" i="1" smtClean="0">
-                            <a:latin typeface="Cambria Math" panose="02040503050406030204" pitchFamily="18" charset="0"/>
-                          </a:rPr>
-                          <m:t>𝑏𝑘𝑔</m:t>
-                        </m:r>
-                      </m:sub>
-                    </m:sSub>
-                    <m:r>
-                      <a:rPr lang="en-US" b="0" i="1" smtClean="0">
-                        <a:latin typeface="Cambria Math" panose="02040503050406030204" pitchFamily="18" charset="0"/>
-                      </a:rPr>
-                      <m:t>(</m:t>
-                    </m:r>
-                    <m:r>
-                      <a:rPr lang="en-US" b="0" i="1" smtClean="0">
-                        <a:latin typeface="Cambria Math" panose="02040503050406030204" pitchFamily="18" charset="0"/>
-                      </a:rPr>
-                      <m:t>𝑥</m:t>
-                    </m:r>
-                    <m:r>
-                      <a:rPr lang="en-US" b="0" i="1" smtClean="0">
-                        <a:latin typeface="Cambria Math" panose="02040503050406030204" pitchFamily="18" charset="0"/>
-                      </a:rPr>
-                      <m:t>)</m:t>
-                    </m:r>
-                  </m:oMath>
-                </a14:m>
-                <a:r>
-                  <a:rPr lang="en-US" dirty="0"/>
-                  <a:t> </a:t>
-                </a:r>
-              </a:p>
-            </p:txBody>
-          </p:sp>
-        </mc:Choice>
-        <mc:Fallback xmlns="">
-          <p:sp>
-            <p:nvSpPr>
-              <p:cNvPr id="8" name="Content Placeholder 7">
-                <a:extLst>
-                  <a:ext uri="{FF2B5EF4-FFF2-40B4-BE49-F238E27FC236}">
-                    <a16:creationId xmlns:a16="http://schemas.microsoft.com/office/drawing/2014/main" id="{8D840D64-988A-B2AF-C8A3-9D1A4702914B}"/>
-                  </a:ext>
-                </a:extLst>
-              </p:cNvPr>
-              <p:cNvSpPr>
-                <a:spLocks noGrp="1" noRot="1" noChangeAspect="1" noMove="1" noResize="1" noEditPoints="1" noAdjustHandles="1" noChangeArrowheads="1" noChangeShapeType="1" noTextEdit="1"/>
-              </p:cNvSpPr>
-              <p:nvPr>
-                <p:ph idx="1"/>
-              </p:nvPr>
-            </p:nvSpPr>
-            <p:spPr>
-              <a:xfrm>
-                <a:off x="711200" y="1295400"/>
-                <a:ext cx="7975600" cy="4819650"/>
-              </a:xfrm>
-              <a:blipFill>
-                <a:blip r:embed="rId2"/>
-                <a:stretch>
-                  <a:fillRect l="-1274" t="-1316" r="-637"/>
-                </a:stretch>
-              </a:blipFill>
-            </p:spPr>
-            <p:txBody>
-              <a:bodyPr/>
-              <a:lstStyle/>
-              <a:p>
-                <a:r>
-                  <a:rPr lang="en-US">
-                    <a:noFill/>
-                  </a:rPr>
-                  <a:t> </a:t>
-                </a:r>
-              </a:p>
-            </p:txBody>
-          </p:sp>
-        </mc:Fallback>
-      </mc:AlternateContent>
-      <p:sp>
-        <p:nvSpPr>
-          <p:cNvPr id="7" name="Title 6">
-            <a:extLst>
-              <a:ext uri="{FF2B5EF4-FFF2-40B4-BE49-F238E27FC236}">
-                <a16:creationId xmlns:a16="http://schemas.microsoft.com/office/drawing/2014/main" id="{7B8D65E0-9012-74C2-B560-CF6F4601D029}"/>
-              </a:ext>
-            </a:extLst>
-          </p:cNvPr>
-          <p:cNvSpPr>
-            <a:spLocks noGrp="1"/>
-          </p:cNvSpPr>
-          <p:nvPr>
-            <p:ph type="title"/>
-          </p:nvPr>
-        </p:nvSpPr>
-        <p:spPr/>
-        <p:txBody>
-          <a:bodyPr/>
-          <a:lstStyle/>
-          <a:p>
-            <a:r>
-              <a:rPr lang="en-US" dirty="0"/>
-              <a:t>Anomaly Detection</a:t>
-            </a:r>
-            <a:endParaRPr lang="en-US" dirty="0">
-              <a:solidFill>
-                <a:schemeClr val="accent1"/>
-              </a:solidFill>
-            </a:endParaRPr>
-          </a:p>
-        </p:txBody>
-      </p:sp>
-    </p:spTree>
-    <p:extLst>
-      <p:ext uri="{BB962C8B-B14F-4D97-AF65-F5344CB8AC3E}">
-        <p14:creationId xmlns:p14="http://schemas.microsoft.com/office/powerpoint/2010/main" val="2180012468"/>
-      </p:ext>
-    </p:extLst>
-  </p:cSld>
-  <p:clrMapOvr>
-    <a:masterClrMapping/>
-  </p:clrMapOvr>
-  <mc:AlternateContent xmlns:mc="http://schemas.openxmlformats.org/markup-compatibility/2006" xmlns:p14="http://schemas.microsoft.com/office/powerpoint/2010/main">
-    <mc:Choice Requires="p14">
-      <p:transition spd="med" p14:dur="700">
-        <p:fade/>
-      </p:transition>
-    </mc:Choice>
-    <mc:Fallback xmlns="">
-      <p:transition spd="med">
-        <p:fade/>
-      </p:transition>
-    </mc:Fallback>
-  </mc:AlternateContent>
-</p:sld>
-</file>
-
-<file path=ppt/slides/slide9.xml><?xml version="1.0" encoding="utf-8"?>
-<p:sld xmlns:a="http://schemas.openxmlformats.org/drawingml/2006/main" xmlns:r="http://schemas.openxmlformats.org/officeDocument/2006/relationships" xmlns:p="http://schemas.openxmlformats.org/presentationml/2006/main">
-  <p:cSld>
-    <p:spTree>
-      <p:nvGrpSpPr>
-        <p:cNvPr id="1" name="">
-          <a:extLst>
-            <a:ext uri="{FF2B5EF4-FFF2-40B4-BE49-F238E27FC236}">
               <a16:creationId xmlns:a16="http://schemas.microsoft.com/office/drawing/2014/main" id="{E12ADE53-32C9-6F16-DF12-A31D61876B00}"/>
             </a:ext>
           </a:extLst>
@@ -6507,19 +5859,15 @@
             </a:pPr>
             <a:r>
               <a:rPr lang="en-US" dirty="0"/>
-              <a:t>Your Paper, which should be </a:t>
-            </a:r>
-            <a:r>
-              <a:rPr lang="en-US" dirty="0">
-                <a:solidFill>
-                  <a:srgbClr val="0033CC"/>
-                </a:solidFill>
-              </a:rPr>
-              <a:t>between 5 and 8 pages</a:t>
+              <a:t>Your write-up, using markdown, in the </a:t>
+            </a:r>
+            <a:r>
+              <a:rPr lang="en-US" dirty="0" err="1"/>
+              <a:t>jupyter</a:t>
             </a:r>
             <a:r>
               <a:rPr lang="en-US" dirty="0"/>
-              <a:t>, excluding references, must include the following elements and sections:</a:t>
+              <a:t> notebook must include the following elements and sections:</a:t>
             </a:r>
           </a:p>
           <a:p>
@@ -6630,7 +5978,15 @@
           <a:p>
             <a:r>
               <a:rPr lang="en-US" dirty="0"/>
-              <a:t>Writeup</a:t>
+              <a:t>Writeup in </a:t>
+            </a:r>
+            <a:r>
+              <a:rPr lang="en-US" dirty="0" err="1"/>
+              <a:t>Jupyter</a:t>
+            </a:r>
+            <a:r>
+              <a:rPr lang="en-US" dirty="0"/>
+              <a:t> Notebook</a:t>
             </a:r>
             <a:endParaRPr lang="en-US" dirty="0">
               <a:solidFill>
@@ -6644,6 +6000,179 @@
     <p:extLst>
       <p:ext uri="{BB962C8B-B14F-4D97-AF65-F5344CB8AC3E}">
         <p14:creationId xmlns:p14="http://schemas.microsoft.com/office/powerpoint/2010/main" val="2447337300"/>
+      </p:ext>
+    </p:extLst>
+  </p:cSld>
+  <p:clrMapOvr>
+    <a:masterClrMapping/>
+  </p:clrMapOvr>
+  <mc:AlternateContent xmlns:mc="http://schemas.openxmlformats.org/markup-compatibility/2006" xmlns:p14="http://schemas.microsoft.com/office/powerpoint/2010/main">
+    <mc:Choice Requires="p14">
+      <p:transition spd="med" p14:dur="700">
+        <p:fade/>
+      </p:transition>
+    </mc:Choice>
+    <mc:Fallback xmlns="">
+      <p:transition spd="med">
+        <p:fade/>
+      </p:transition>
+    </mc:Fallback>
+  </mc:AlternateContent>
+</p:sld>
+</file>
+
+<file path=ppt/slides/slide9.xml><?xml version="1.0" encoding="utf-8"?>
+<p:sld xmlns:a="http://schemas.openxmlformats.org/drawingml/2006/main" xmlns:r="http://schemas.openxmlformats.org/officeDocument/2006/relationships" xmlns:p="http://schemas.openxmlformats.org/presentationml/2006/main">
+  <p:cSld>
+    <p:spTree>
+      <p:nvGrpSpPr>
+        <p:cNvPr id="1" name="">
+          <a:extLst>
+            <a:ext uri="{FF2B5EF4-FFF2-40B4-BE49-F238E27FC236}">
+              <a16:creationId xmlns:a16="http://schemas.microsoft.com/office/drawing/2014/main" id="{2D38A5AF-461D-C51D-EF42-F91E6FE335EF}"/>
+            </a:ext>
+          </a:extLst>
+        </p:cNvPr>
+        <p:cNvGrpSpPr/>
+        <p:nvPr/>
+      </p:nvGrpSpPr>
+      <p:grpSpPr>
+        <a:xfrm>
+          <a:off x="0" y="0"/>
+          <a:ext cx="0" cy="0"/>
+          <a:chOff x="0" y="0"/>
+          <a:chExt cx="0" cy="0"/>
+        </a:xfrm>
+      </p:grpSpPr>
+      <p:sp>
+        <p:nvSpPr>
+          <p:cNvPr id="8" name="Content Placeholder 7">
+            <a:extLst>
+              <a:ext uri="{FF2B5EF4-FFF2-40B4-BE49-F238E27FC236}">
+                <a16:creationId xmlns:a16="http://schemas.microsoft.com/office/drawing/2014/main" id="{36EBA238-9761-443C-E110-F9D0F75D067A}"/>
+              </a:ext>
+            </a:extLst>
+          </p:cNvPr>
+          <p:cNvSpPr>
+            <a:spLocks noGrp="1"/>
+          </p:cNvSpPr>
+          <p:nvPr>
+            <p:ph idx="1"/>
+          </p:nvPr>
+        </p:nvSpPr>
+        <p:spPr>
+          <a:xfrm>
+            <a:off x="711200" y="1295400"/>
+            <a:ext cx="7975600" cy="4819650"/>
+          </a:xfrm>
+        </p:spPr>
+        <p:txBody>
+          <a:bodyPr/>
+          <a:lstStyle/>
+          <a:p>
+            <a:pPr marL="514350" indent="-514350">
+              <a:buFont typeface="+mj-lt"/>
+              <a:buAutoNum type="arabicPeriod"/>
+            </a:pPr>
+            <a:r>
+              <a:rPr lang="en-US" dirty="0"/>
+              <a:t>Class time (both Tuesdays and Thursdays) will be devoted your project. You’re strongly advised to show up!</a:t>
+            </a:r>
+            <a:br>
+              <a:rPr lang="en-US" dirty="0"/>
+            </a:br>
+            <a:endParaRPr lang="en-US" dirty="0"/>
+          </a:p>
+          <a:p>
+            <a:pPr marL="514350" indent="-514350">
+              <a:buFont typeface="+mj-lt"/>
+              <a:buAutoNum type="arabicPeriod"/>
+            </a:pPr>
+            <a:r>
+              <a:rPr lang="en-US" dirty="0"/>
+              <a:t>You are free to help each other, but your paper must be your own.</a:t>
+            </a:r>
+            <a:br>
+              <a:rPr lang="en-US" dirty="0"/>
+            </a:br>
+            <a:endParaRPr lang="en-US" dirty="0"/>
+          </a:p>
+          <a:p>
+            <a:pPr marL="514350" indent="-514350">
+              <a:buFont typeface="+mj-lt"/>
+              <a:buAutoNum type="arabicPeriod"/>
+            </a:pPr>
+            <a:r>
+              <a:rPr lang="en-US" dirty="0"/>
+              <a:t>You are free to use any resources, but you must cite all of them.</a:t>
+            </a:r>
+            <a:br>
+              <a:rPr lang="en-US" dirty="0"/>
+            </a:br>
+            <a:endParaRPr lang="en-US" dirty="0"/>
+          </a:p>
+          <a:p>
+            <a:pPr marL="514350" indent="-514350">
+              <a:buFont typeface="+mj-lt"/>
+              <a:buAutoNum type="arabicPeriod"/>
+            </a:pPr>
+            <a:r>
+              <a:rPr lang="en-US" dirty="0"/>
+              <a:t>You must document the data used, the architecture of your model, the training protocol and the results.</a:t>
+            </a:r>
+            <a:br>
+              <a:rPr lang="en-US" dirty="0"/>
+            </a:br>
+            <a:r>
+              <a:rPr lang="en-US" dirty="0"/>
+              <a:t> </a:t>
+            </a:r>
+          </a:p>
+          <a:p>
+            <a:pPr marL="0" indent="0">
+              <a:buNone/>
+            </a:pPr>
+            <a:endParaRPr lang="en-US" sz="1800" dirty="0"/>
+          </a:p>
+        </p:txBody>
+      </p:sp>
+      <p:sp>
+        <p:nvSpPr>
+          <p:cNvPr id="7" name="Title 6">
+            <a:extLst>
+              <a:ext uri="{FF2B5EF4-FFF2-40B4-BE49-F238E27FC236}">
+                <a16:creationId xmlns:a16="http://schemas.microsoft.com/office/drawing/2014/main" id="{0C0FF786-FAA9-F3FC-5433-937C3E994692}"/>
+              </a:ext>
+            </a:extLst>
+          </p:cNvPr>
+          <p:cNvSpPr>
+            <a:spLocks noGrp="1"/>
+          </p:cNvSpPr>
+          <p:nvPr>
+            <p:ph type="title"/>
+          </p:nvPr>
+        </p:nvSpPr>
+        <p:spPr/>
+        <p:txBody>
+          <a:bodyPr/>
+          <a:lstStyle/>
+          <a:p>
+            <a:r>
+              <a:rPr lang="en-US" dirty="0"/>
+              <a:t>Ground Rules</a:t>
+            </a:r>
+            <a:endParaRPr lang="en-US" dirty="0">
+              <a:solidFill>
+                <a:schemeClr val="accent1"/>
+              </a:solidFill>
+            </a:endParaRPr>
+          </a:p>
+        </p:txBody>
+      </p:sp>
+    </p:spTree>
+    <p:extLst>
+      <p:ext uri="{BB962C8B-B14F-4D97-AF65-F5344CB8AC3E}">
+        <p14:creationId xmlns:p14="http://schemas.microsoft.com/office/powerpoint/2010/main" val="4132763623"/>
       </p:ext>
     </p:extLst>
   </p:cSld>

</xml_diff>